<commit_message>
Atualiza slides da Aula 2 e adiciona tarefa pre-aula faltante
Slide revisado publicado via atualizar_slides.py. Adiciona pre_aula.tarefa
(3 perguntas) ao _aula.yaml, extraidas e conferidas contra a secao 1.3 do
Plano_de_Aula.docx - faltavam no site, template ja renderiza na ordem
leitura -> videos -> tarefa.

scripts/atualizar_slides.py ganha filtro --aula <slug> (repetivel) para
aplicar seletivamente quando alguma aula tiver divergencia que precise
ser investigada antes de sincronizar.
</commit_message>
<xml_diff>
--- a/content/2026-2/cea055-estatistica-probabilidade/02-estatistica-descritiva-ii/Aula_02_Estatistica_Descritiva_II.pptx
+++ b/content/2026-2/cea055-estatistica-probabilidade/02-estatistica-descritiva-ii/Aula_02_Estatistica_Descritiva_II.pptx
@@ -5,7 +5,7 @@
     <p:sldMasterId id="2147483648" r:id="rId1"/>
   </p:sldMasterIdLst>
   <p:notesMasterIdLst>
-    <p:notesMasterId r:id="rId19"/>
+    <p:notesMasterId r:id="rId18"/>
   </p:notesMasterIdLst>
   <p:sldIdLst>
     <p:sldId id="292" r:id="rId2"/>
@@ -17,14 +17,13 @@
     <p:sldId id="299" r:id="rId8"/>
     <p:sldId id="314" r:id="rId9"/>
     <p:sldId id="301" r:id="rId10"/>
-    <p:sldId id="302" r:id="rId11"/>
-    <p:sldId id="315" r:id="rId12"/>
-    <p:sldId id="304" r:id="rId13"/>
-    <p:sldId id="305" r:id="rId14"/>
-    <p:sldId id="306" r:id="rId15"/>
-    <p:sldId id="319" r:id="rId16"/>
-    <p:sldId id="320" r:id="rId17"/>
-    <p:sldId id="311" r:id="rId18"/>
+    <p:sldId id="315" r:id="rId11"/>
+    <p:sldId id="304" r:id="rId12"/>
+    <p:sldId id="305" r:id="rId13"/>
+    <p:sldId id="306" r:id="rId14"/>
+    <p:sldId id="319" r:id="rId15"/>
+    <p:sldId id="320" r:id="rId16"/>
+    <p:sldId id="311" r:id="rId17"/>
   </p:sldIdLst>
   <p:sldSz cx="12192000" cy="6858000"/>
   <p:notesSz cx="6858000" cy="9144000"/>
@@ -620,8 +619,8 @@
               <a:defRPr sz="1600" b="1"/>
             </a:pPr>
             <a:r>
-              <a:rPr lang="pt-BR" sz="1600" b="1"/>
-              <a:t>(b) Assimétrica Negativa</a:t>
+              <a:rPr lang="pt-BR" sz="1600" b="1" dirty="0"/>
+              <a:t>(b) Assimétrica Negativa (ou á esquerda)</a:t>
             </a:r>
           </a:p>
         </c:rich>
@@ -858,8 +857,8 @@
               <a:defRPr sz="1600" b="1"/>
             </a:pPr>
             <a:r>
-              <a:rPr lang="pt-BR" sz="1600" b="1"/>
-              <a:t>(c) Assimétrica Positiva</a:t>
+              <a:rPr lang="pt-BR" sz="1600" b="1" dirty="0"/>
+              <a:t>(c) Assimétrica Positiva (ou à direita)</a:t>
             </a:r>
           </a:p>
         </c:rich>
@@ -1161,7 +1160,7 @@
           <a:p>
             <a:fld id="{44623A65-BD25-40B6-8815-498297225DF7}" type="datetimeFigureOut">
               <a:rPr lang="pt-BR" smtClean="0"/>
-              <a:t>07/08/2026</a:t>
+              <a:t>26/08/2026</a:t>
             </a:fld>
             <a:endParaRPr lang="pt-BR" dirty="0"/>
           </a:p>
@@ -1498,7 +1497,7 @@
           <a:p>
             <a:fld id="{7D7F89C7-0D7F-4B10-AF98-1416A21C67FE}" type="slidenum">
               <a:rPr lang="pt-BR" smtClean="0"/>
-              <a:t>17</a:t>
+              <a:t>16</a:t>
             </a:fld>
             <a:endParaRPr lang="pt-BR" dirty="0"/>
           </a:p>
@@ -1664,7 +1663,7 @@
           <a:p>
             <a:fld id="{5B45E566-B383-4B2D-B951-1136FD38326E}" type="datetimeFigureOut">
               <a:rPr lang="pt-BR" smtClean="0"/>
-              <a:t>07/08/2026</a:t>
+              <a:t>26/08/2026</a:t>
             </a:fld>
             <a:endParaRPr lang="pt-BR" dirty="0"/>
           </a:p>
@@ -1862,7 +1861,7 @@
           <a:p>
             <a:fld id="{5B45E566-B383-4B2D-B951-1136FD38326E}" type="datetimeFigureOut">
               <a:rPr lang="pt-BR" smtClean="0"/>
-              <a:t>07/08/2026</a:t>
+              <a:t>26/08/2026</a:t>
             </a:fld>
             <a:endParaRPr lang="pt-BR" dirty="0"/>
           </a:p>
@@ -2070,7 +2069,7 @@
           <a:p>
             <a:fld id="{5B45E566-B383-4B2D-B951-1136FD38326E}" type="datetimeFigureOut">
               <a:rPr lang="pt-BR" smtClean="0"/>
-              <a:t>07/08/2026</a:t>
+              <a:t>26/08/2026</a:t>
             </a:fld>
             <a:endParaRPr lang="pt-BR" dirty="0"/>
           </a:p>
@@ -2268,7 +2267,7 @@
           <a:p>
             <a:fld id="{5B45E566-B383-4B2D-B951-1136FD38326E}" type="datetimeFigureOut">
               <a:rPr lang="pt-BR" smtClean="0"/>
-              <a:t>07/08/2026</a:t>
+              <a:t>26/08/2026</a:t>
             </a:fld>
             <a:endParaRPr lang="pt-BR" dirty="0"/>
           </a:p>
@@ -2543,7 +2542,7 @@
           <a:p>
             <a:fld id="{5B45E566-B383-4B2D-B951-1136FD38326E}" type="datetimeFigureOut">
               <a:rPr lang="pt-BR" smtClean="0"/>
-              <a:t>07/08/2026</a:t>
+              <a:t>26/08/2026</a:t>
             </a:fld>
             <a:endParaRPr lang="pt-BR" dirty="0"/>
           </a:p>
@@ -2808,7 +2807,7 @@
           <a:p>
             <a:fld id="{5B45E566-B383-4B2D-B951-1136FD38326E}" type="datetimeFigureOut">
               <a:rPr lang="pt-BR" smtClean="0"/>
-              <a:t>07/08/2026</a:t>
+              <a:t>26/08/2026</a:t>
             </a:fld>
             <a:endParaRPr lang="pt-BR" dirty="0"/>
           </a:p>
@@ -3220,7 +3219,7 @@
           <a:p>
             <a:fld id="{5B45E566-B383-4B2D-B951-1136FD38326E}" type="datetimeFigureOut">
               <a:rPr lang="pt-BR" smtClean="0"/>
-              <a:t>07/08/2026</a:t>
+              <a:t>26/08/2026</a:t>
             </a:fld>
             <a:endParaRPr lang="pt-BR" dirty="0"/>
           </a:p>
@@ -3361,7 +3360,7 @@
           <a:p>
             <a:fld id="{5B45E566-B383-4B2D-B951-1136FD38326E}" type="datetimeFigureOut">
               <a:rPr lang="pt-BR" smtClean="0"/>
-              <a:t>07/08/2026</a:t>
+              <a:t>26/08/2026</a:t>
             </a:fld>
             <a:endParaRPr lang="pt-BR" dirty="0"/>
           </a:p>
@@ -3474,7 +3473,7 @@
           <a:p>
             <a:fld id="{5B45E566-B383-4B2D-B951-1136FD38326E}" type="datetimeFigureOut">
               <a:rPr lang="pt-BR" smtClean="0"/>
-              <a:t>07/08/2026</a:t>
+              <a:t>26/08/2026</a:t>
             </a:fld>
             <a:endParaRPr lang="pt-BR" dirty="0"/>
           </a:p>
@@ -3785,7 +3784,7 @@
           <a:p>
             <a:fld id="{5B45E566-B383-4B2D-B951-1136FD38326E}" type="datetimeFigureOut">
               <a:rPr lang="pt-BR" smtClean="0"/>
-              <a:t>07/08/2026</a:t>
+              <a:t>26/08/2026</a:t>
             </a:fld>
             <a:endParaRPr lang="pt-BR" dirty="0"/>
           </a:p>
@@ -4073,7 +4072,7 @@
           <a:p>
             <a:fld id="{5B45E566-B383-4B2D-B951-1136FD38326E}" type="datetimeFigureOut">
               <a:rPr lang="pt-BR" smtClean="0"/>
-              <a:t>07/08/2026</a:t>
+              <a:t>26/08/2026</a:t>
             </a:fld>
             <a:endParaRPr lang="pt-BR" dirty="0"/>
           </a:p>
@@ -4338,7 +4337,7 @@
           <a:p>
             <a:fld id="{5B45E566-B383-4B2D-B951-1136FD38326E}" type="datetimeFigureOut">
               <a:rPr lang="pt-BR" smtClean="0"/>
-              <a:t>07/08/2026</a:t>
+              <a:t>26/08/2026</a:t>
             </a:fld>
             <a:endParaRPr lang="pt-BR" dirty="0"/>
           </a:p>
@@ -5089,169 +5088,6 @@
         </p:nvSpPr>
         <p:spPr>
           <a:xfrm>
-            <a:off x="505817" y="843768"/>
-            <a:ext cx="11180365" cy="954107"/>
-          </a:xfrm>
-          <a:prstGeom prst="rect">
-            <a:avLst/>
-          </a:prstGeom>
-          <a:noFill/>
-        </p:spPr>
-        <p:txBody>
-          <a:bodyPr wrap="square" rtlCol="0">
-            <a:spAutoFit/>
-          </a:bodyPr>
-          <a:lstStyle/>
-          <a:p>
-            <a:r>
-              <a:rPr lang="pt-BR" sz="2800" b="1" dirty="0"/>
-              <a:t>Mais algumas definições</a:t>
-            </a:r>
-          </a:p>
-          <a:p>
-            <a:endParaRPr lang="pt-BR" sz="2800" b="1" dirty="0"/>
-          </a:p>
-        </p:txBody>
-      </p:sp>
-      <p:sp>
-        <p:nvSpPr>
-          <p:cNvPr id="3" name="CaixaDeTexto 2">
-            <a:extLst>
-              <a:ext uri="{FF2B5EF4-FFF2-40B4-BE49-F238E27FC236}">
-                <a16:creationId xmlns:a16="http://schemas.microsoft.com/office/drawing/2014/main" id="{19131A04-B5D6-4211-8B49-4615DE5797E9}"/>
-              </a:ext>
-            </a:extLst>
-          </p:cNvPr>
-          <p:cNvSpPr txBox="1"/>
-          <p:nvPr/>
-        </p:nvSpPr>
-        <p:spPr>
-          <a:xfrm>
-            <a:off x="361395" y="6488668"/>
-            <a:ext cx="4658776" cy="300210"/>
-          </a:xfrm>
-          <a:prstGeom prst="rect">
-            <a:avLst/>
-          </a:prstGeom>
-          <a:noFill/>
-        </p:spPr>
-        <p:txBody>
-          <a:bodyPr wrap="none" rtlCol="0">
-            <a:spAutoFit/>
-          </a:bodyPr>
-          <a:lstStyle/>
-          <a:p>
-            <a:r>
-              <a:rPr lang="pt-BR" sz="1351" dirty="0"/>
-              <a:t>CEA055 - Estatística e Probabilidade - Prof. Marcos Goulart Lima</a:t>
-            </a:r>
-          </a:p>
-        </p:txBody>
-      </p:sp>
-      <p:pic>
-        <p:nvPicPr>
-          <p:cNvPr id="7" name="Imagem 6">
-            <a:extLst>
-              <a:ext uri="{FF2B5EF4-FFF2-40B4-BE49-F238E27FC236}">
-                <a16:creationId xmlns:a16="http://schemas.microsoft.com/office/drawing/2014/main" id="{E764A055-2D4A-45CA-8FEB-BED3DE509FBE}"/>
-              </a:ext>
-            </a:extLst>
-          </p:cNvPr>
-          <p:cNvPicPr>
-            <a:picLocks noChangeAspect="1"/>
-          </p:cNvPicPr>
-          <p:nvPr/>
-        </p:nvPicPr>
-        <p:blipFill>
-          <a:blip r:embed="rId2"/>
-          <a:stretch>
-            <a:fillRect/>
-          </a:stretch>
-        </p:blipFill>
-        <p:spPr>
-          <a:xfrm>
-            <a:off x="1934924" y="1501027"/>
-            <a:ext cx="8610991" cy="1927973"/>
-          </a:xfrm>
-          <a:prstGeom prst="rect">
-            <a:avLst/>
-          </a:prstGeom>
-        </p:spPr>
-      </p:pic>
-      <p:pic>
-        <p:nvPicPr>
-          <p:cNvPr id="9" name="Imagem 8">
-            <a:extLst>
-              <a:ext uri="{FF2B5EF4-FFF2-40B4-BE49-F238E27FC236}">
-                <a16:creationId xmlns:a16="http://schemas.microsoft.com/office/drawing/2014/main" id="{2B8C5C3B-6FE8-4CB8-9B68-5D9B4E620FFF}"/>
-              </a:ext>
-            </a:extLst>
-          </p:cNvPr>
-          <p:cNvPicPr>
-            <a:picLocks noChangeAspect="1"/>
-          </p:cNvPicPr>
-          <p:nvPr/>
-        </p:nvPicPr>
-        <p:blipFill>
-          <a:blip r:embed="rId3"/>
-          <a:stretch>
-            <a:fillRect/>
-          </a:stretch>
-        </p:blipFill>
-        <p:spPr>
-          <a:xfrm>
-            <a:off x="4200259" y="3536374"/>
-            <a:ext cx="3791479" cy="2457793"/>
-          </a:xfrm>
-          <a:prstGeom prst="rect">
-            <a:avLst/>
-          </a:prstGeom>
-        </p:spPr>
-      </p:pic>
-    </p:spTree>
-    <p:extLst>
-      <p:ext uri="{BB962C8B-B14F-4D97-AF65-F5344CB8AC3E}">
-        <p14:creationId xmlns:p14="http://schemas.microsoft.com/office/powerpoint/2010/main" val="2199814263"/>
-      </p:ext>
-    </p:extLst>
-  </p:cSld>
-  <p:clrMapOvr>
-    <a:masterClrMapping/>
-  </p:clrMapOvr>
-</p:sld>
-</file>
-
-<file path=ppt/slides/slide11.xml><?xml version="1.0" encoding="utf-8"?>
-<p:sld xmlns:a="http://schemas.openxmlformats.org/drawingml/2006/main" xmlns:r="http://schemas.openxmlformats.org/officeDocument/2006/relationships" xmlns:p="http://schemas.openxmlformats.org/presentationml/2006/main">
-  <p:cSld>
-    <p:spTree>
-      <p:nvGrpSpPr>
-        <p:cNvPr id="1" name=""/>
-        <p:cNvGrpSpPr/>
-        <p:nvPr/>
-      </p:nvGrpSpPr>
-      <p:grpSpPr>
-        <a:xfrm>
-          <a:off x="0" y="0"/>
-          <a:ext cx="0" cy="0"/>
-          <a:chOff x="0" y="0"/>
-          <a:chExt cx="0" cy="0"/>
-        </a:xfrm>
-      </p:grpSpPr>
-      <p:sp>
-        <p:nvSpPr>
-          <p:cNvPr id="6" name="CaixaDeTexto 5">
-            <a:extLst>
-              <a:ext uri="{FF2B5EF4-FFF2-40B4-BE49-F238E27FC236}">
-                <a16:creationId xmlns:a16="http://schemas.microsoft.com/office/drawing/2014/main" id="{720B10DA-C761-4DEE-8D86-E170E1C2E981}"/>
-              </a:ext>
-            </a:extLst>
-          </p:cNvPr>
-          <p:cNvSpPr txBox="1"/>
-          <p:nvPr/>
-        </p:nvSpPr>
-        <p:spPr>
-          <a:xfrm>
             <a:off x="505817" y="679587"/>
             <a:ext cx="11180365" cy="954107"/>
           </a:xfrm>
@@ -5346,8 +5182,8 @@
           </a:prstGeom>
         </p:spPr>
       </p:pic>
-      <mc:AlternateContent xmlns:mc="http://schemas.openxmlformats.org/markup-compatibility/2006" xmlns:a14="http://schemas.microsoft.com/office/drawing/2010/main">
-        <mc:Choice Requires="a14">
+      <mc:AlternateContent xmlns:mc="http://schemas.openxmlformats.org/markup-compatibility/2006">
+        <mc:Choice xmlns:a14="http://schemas.microsoft.com/office/drawing/2010/main" Requires="a14">
           <p:sp>
             <p:nvSpPr>
               <p:cNvPr id="4" name="BoxplotExplanation">
@@ -5363,7 +5199,7 @@
             <p:spPr>
               <a:xfrm>
                 <a:off x="505817" y="1156640"/>
-                <a:ext cx="5969000" cy="5295809"/>
+                <a:ext cx="5969000" cy="3487558"/>
               </a:xfrm>
               <a:prstGeom prst="rect">
                 <a:avLst/>
@@ -5383,7 +5219,7 @@
                   <a:buNone/>
                 </a:pPr>
                 <a:r>
-                  <a:rPr lang="pt-BR" sz="2800" b="1" dirty="0"/>
+                  <a:rPr lang="pt-BR" sz="2400" b="1" dirty="0"/>
                   <a:t>Limites do Box Plot</a:t>
                 </a:r>
               </a:p>
@@ -5395,29 +5231,106 @@
                   <a:buFont typeface="Arial" panose="020B0604020202020204" pitchFamily="34" charset="0"/>
                   <a:buChar char="•"/>
                 </a:pPr>
+                <a14:m>
+                  <m:oMath xmlns:m="http://schemas.openxmlformats.org/officeDocument/2006/math">
+                    <m:sSub>
+                      <m:sSubPr>
+                        <m:ctrlPr>
+                          <a:rPr lang="pt-BR" sz="2400" b="0" i="1" dirty="0" smtClean="0">
+                            <a:latin typeface="Cambria Math" panose="02040503050406030204" pitchFamily="18" charset="0"/>
+                          </a:rPr>
+                        </m:ctrlPr>
+                      </m:sSubPr>
+                      <m:e>
+                        <m:r>
+                          <a:rPr lang="pt-BR" sz="2400" i="1" dirty="0" smtClean="0">
+                            <a:latin typeface="Cambria Math" panose="02040503050406030204" pitchFamily="18" charset="0"/>
+                          </a:rPr>
+                          <m:t>𝑑</m:t>
+                        </m:r>
+                      </m:e>
+                      <m:sub>
+                        <m:r>
+                          <a:rPr lang="pt-BR" sz="2400" i="1" dirty="0" smtClean="0">
+                            <a:latin typeface="Cambria Math" panose="02040503050406030204" pitchFamily="18" charset="0"/>
+                          </a:rPr>
+                          <m:t>𝑞</m:t>
+                        </m:r>
+                      </m:sub>
+                    </m:sSub>
+                    <m:r>
+                      <a:rPr lang="pt-BR" sz="2400" i="1" dirty="0" smtClean="0">
+                        <a:latin typeface="Cambria Math" panose="02040503050406030204" pitchFamily="18" charset="0"/>
+                      </a:rPr>
+                      <m:t>= </m:t>
+                    </m:r>
+                    <m:sSub>
+                      <m:sSubPr>
+                        <m:ctrlPr>
+                          <a:rPr lang="pt-BR" sz="2400" b="0" i="1" dirty="0" smtClean="0">
+                            <a:latin typeface="Cambria Math" panose="02040503050406030204" pitchFamily="18" charset="0"/>
+                          </a:rPr>
+                        </m:ctrlPr>
+                      </m:sSubPr>
+                      <m:e>
+                        <m:r>
+                          <a:rPr lang="pt-BR" sz="2400" b="0" i="1" dirty="0" smtClean="0">
+                            <a:latin typeface="Cambria Math" panose="02040503050406030204" pitchFamily="18" charset="0"/>
+                          </a:rPr>
+                          <m:t>𝑞</m:t>
+                        </m:r>
+                      </m:e>
+                      <m:sub>
+                        <m:r>
+                          <a:rPr lang="pt-BR" sz="2400" b="0" i="1" dirty="0" smtClean="0">
+                            <a:latin typeface="Cambria Math" panose="02040503050406030204" pitchFamily="18" charset="0"/>
+                          </a:rPr>
+                          <m:t>3</m:t>
+                        </m:r>
+                      </m:sub>
+                    </m:sSub>
+                    <m:r>
+                      <a:rPr lang="pt-BR" sz="2400" i="1" dirty="0" smtClean="0">
+                        <a:latin typeface="Cambria Math" panose="02040503050406030204" pitchFamily="18" charset="0"/>
+                      </a:rPr>
+                      <m:t>−</m:t>
+                    </m:r>
+                    <m:sSub>
+                      <m:sSubPr>
+                        <m:ctrlPr>
+                          <a:rPr lang="pt-BR" sz="2400" b="0" i="1" dirty="0" smtClean="0">
+                            <a:latin typeface="Cambria Math" panose="02040503050406030204" pitchFamily="18" charset="0"/>
+                          </a:rPr>
+                        </m:ctrlPr>
+                      </m:sSubPr>
+                      <m:e>
+                        <m:r>
+                          <a:rPr lang="pt-BR" sz="2400" b="0" i="1" dirty="0" smtClean="0">
+                            <a:latin typeface="Cambria Math" panose="02040503050406030204" pitchFamily="18" charset="0"/>
+                          </a:rPr>
+                          <m:t>𝑞</m:t>
+                        </m:r>
+                      </m:e>
+                      <m:sub>
+                        <m:r>
+                          <a:rPr lang="pt-BR" sz="2400" b="0" i="1" dirty="0" smtClean="0">
+                            <a:latin typeface="Cambria Math" panose="02040503050406030204" pitchFamily="18" charset="0"/>
+                          </a:rPr>
+                          <m:t>1</m:t>
+                        </m:r>
+                      </m:sub>
+                    </m:sSub>
+                    <m:r>
+                      <a:rPr lang="pt-BR" sz="2400" i="1" dirty="0" smtClean="0">
+                        <a:latin typeface="Cambria Math" panose="02040503050406030204" pitchFamily="18" charset="0"/>
+                      </a:rPr>
+                      <m:t> </m:t>
+                    </m:r>
+                  </m:oMath>
+                </a14:m>
                 <a:r>
-                  <a:rPr lang="pt-BR" sz="2800" i="1" dirty="0"/>
-                  <a:t>dq</a:t>
-                </a:r>
-                <a:r>
-                  <a:rPr lang="pt-BR" sz="2800" dirty="0"/>
-                  <a:t> = </a:t>
-                </a:r>
-                <a:r>
-                  <a:rPr lang="pt-BR" sz="2800" i="1" dirty="0"/>
-                  <a:t>Q3</a:t>
-                </a:r>
-                <a:r>
-                  <a:rPr lang="pt-BR" sz="2800" dirty="0"/>
-                  <a:t> − </a:t>
-                </a:r>
-                <a:r>
-                  <a:rPr lang="pt-BR" sz="2800" i="1" dirty="0"/>
-                  <a:t>Q1</a:t>
-                </a:r>
-                <a:r>
-                  <a:rPr lang="pt-BR" sz="2800" dirty="0"/>
-                  <a:t> — distância interquartílica</a:t>
+                  <a:rPr lang="pt-BR" sz="2400" dirty="0"/>
+                  <a:t>— distância interquartil</a:t>
                 </a:r>
               </a:p>
               <a:p>
@@ -5428,12 +5341,18 @@
                   <a:buFont typeface="Arial" panose="020B0604020202020204" pitchFamily="34" charset="0"/>
                   <a:buChar char="•"/>
                 </a:pPr>
+                <a14:m>
+                  <m:oMath xmlns:m="http://schemas.openxmlformats.org/officeDocument/2006/math">
+                    <m:r>
+                      <a:rPr lang="pt-BR" sz="2400" b="1" i="1" dirty="0" smtClean="0">
+                        <a:latin typeface="Cambria Math" panose="02040503050406030204" pitchFamily="18" charset="0"/>
+                      </a:rPr>
+                      <m:t>𝑳𝑰</m:t>
+                    </m:r>
+                  </m:oMath>
+                </a14:m>
                 <a:r>
-                  <a:rPr lang="pt-BR" sz="2800" b="1" i="1" dirty="0"/>
-                  <a:t>LI</a:t>
-                </a:r>
-                <a:r>
-                  <a:rPr lang="pt-BR" sz="2800" dirty="0"/>
+                  <a:rPr lang="pt-BR" sz="2400" dirty="0"/>
                   <a:t> (limite inferior) = </a:t>
                 </a:r>
                 <a14:m>
@@ -5441,14 +5360,14 @@
                     <m:sSub>
                       <m:sSubPr>
                         <m:ctrlPr>
-                          <a:rPr lang="pt-BR" sz="2800" b="0" i="1" dirty="0" smtClean="0">
+                          <a:rPr lang="pt-BR" sz="2400" b="0" i="1" dirty="0" smtClean="0">
                             <a:latin typeface="Cambria Math" panose="02040503050406030204" pitchFamily="18" charset="0"/>
                           </a:rPr>
                         </m:ctrlPr>
                       </m:sSubPr>
                       <m:e>
                         <m:r>
-                          <a:rPr lang="pt-BR" sz="2800" i="1" dirty="0" smtClean="0">
+                          <a:rPr lang="pt-BR" sz="2400" i="1" dirty="0" smtClean="0">
                             <a:latin typeface="Cambria Math" panose="02040503050406030204" pitchFamily="18" charset="0"/>
                           </a:rPr>
                           <m:t>𝑄</m:t>
@@ -5456,7 +5375,7 @@
                       </m:e>
                       <m:sub>
                         <m:r>
-                          <a:rPr lang="pt-BR" sz="2800" i="1" dirty="0" smtClean="0">
+                          <a:rPr lang="pt-BR" sz="2400" i="1" dirty="0" smtClean="0">
                             <a:latin typeface="Cambria Math" panose="02040503050406030204" pitchFamily="18" charset="0"/>
                           </a:rPr>
                           <m:t>1</m:t>
@@ -5464,7 +5383,7 @@
                       </m:sub>
                     </m:sSub>
                     <m:r>
-                      <a:rPr lang="pt-BR" sz="2800" i="1" dirty="0" smtClean="0">
+                      <a:rPr lang="pt-BR" sz="2400" i="1" dirty="0" smtClean="0">
                         <a:latin typeface="Cambria Math" panose="02040503050406030204" pitchFamily="18" charset="0"/>
                       </a:rPr>
                       <m:t> − 1,5 × </m:t>
@@ -5472,14 +5391,14 @@
                     <m:sSub>
                       <m:sSubPr>
                         <m:ctrlPr>
-                          <a:rPr lang="pt-BR" sz="2800" b="0" i="1" dirty="0" smtClean="0">
+                          <a:rPr lang="pt-BR" sz="2400" b="0" i="1" dirty="0" smtClean="0">
                             <a:latin typeface="Cambria Math" panose="02040503050406030204" pitchFamily="18" charset="0"/>
                           </a:rPr>
                         </m:ctrlPr>
                       </m:sSubPr>
                       <m:e>
                         <m:r>
-                          <a:rPr lang="pt-BR" sz="2800" i="1" dirty="0" smtClean="0">
+                          <a:rPr lang="pt-BR" sz="2400" i="1" dirty="0" smtClean="0">
                             <a:latin typeface="Cambria Math" panose="02040503050406030204" pitchFamily="18" charset="0"/>
                           </a:rPr>
                           <m:t>𝑑</m:t>
@@ -5487,7 +5406,7 @@
                       </m:e>
                       <m:sub>
                         <m:r>
-                          <a:rPr lang="pt-BR" sz="2800" i="1" dirty="0" smtClean="0">
+                          <a:rPr lang="pt-BR" sz="2400" i="1" dirty="0" smtClean="0">
                             <a:latin typeface="Cambria Math" panose="02040503050406030204" pitchFamily="18" charset="0"/>
                           </a:rPr>
                           <m:t>𝑞</m:t>
@@ -5496,7 +5415,91 @@
                     </m:sSub>
                   </m:oMath>
                 </a14:m>
-                <a:endParaRPr lang="pt-BR" sz="2800" i="1" dirty="0"/>
+                <a:endParaRPr lang="pt-BR" sz="2400" i="1" dirty="0"/>
+              </a:p>
+              <a:p>
+                <a:pPr marL="457178" indent="-457178">
+                  <a:lnSpc>
+                    <a:spcPct val="150000"/>
+                  </a:lnSpc>
+                  <a:buFont typeface="Arial" panose="020B0604020202020204" pitchFamily="34" charset="0"/>
+                  <a:buChar char="•"/>
+                </a:pPr>
+                <a14:m>
+                  <m:oMath xmlns:m="http://schemas.openxmlformats.org/officeDocument/2006/math">
+                    <m:r>
+                      <a:rPr lang="pt-BR" sz="2400" b="1" i="1" dirty="0" smtClean="0">
+                        <a:latin typeface="Cambria Math" panose="02040503050406030204" pitchFamily="18" charset="0"/>
+                      </a:rPr>
+                      <m:t>𝑳𝑺</m:t>
+                    </m:r>
+                  </m:oMath>
+                </a14:m>
+                <a:r>
+                  <a:rPr lang="pt-BR" sz="2400" dirty="0"/>
+                  <a:t> (limite superior) = </a:t>
+                </a:r>
+                <a14:m>
+                  <m:oMath xmlns:m="http://schemas.openxmlformats.org/officeDocument/2006/math">
+                    <m:sSub>
+                      <m:sSubPr>
+                        <m:ctrlPr>
+                          <a:rPr lang="pt-BR" sz="2400" b="0" i="1" dirty="0" smtClean="0">
+                            <a:latin typeface="Cambria Math" panose="02040503050406030204" pitchFamily="18" charset="0"/>
+                          </a:rPr>
+                        </m:ctrlPr>
+                      </m:sSubPr>
+                      <m:e>
+                        <m:r>
+                          <a:rPr lang="pt-BR" sz="2400" i="1" dirty="0" smtClean="0">
+                            <a:latin typeface="Cambria Math" panose="02040503050406030204" pitchFamily="18" charset="0"/>
+                          </a:rPr>
+                          <m:t>𝑄</m:t>
+                        </m:r>
+                      </m:e>
+                      <m:sub>
+                        <m:r>
+                          <a:rPr lang="pt-BR" sz="2400" i="1" dirty="0" smtClean="0">
+                            <a:latin typeface="Cambria Math" panose="02040503050406030204" pitchFamily="18" charset="0"/>
+                          </a:rPr>
+                          <m:t>3</m:t>
+                        </m:r>
+                      </m:sub>
+                    </m:sSub>
+                    <m:r>
+                      <a:rPr lang="pt-BR" sz="2400" i="1" dirty="0" smtClean="0">
+                        <a:latin typeface="Cambria Math" panose="02040503050406030204" pitchFamily="18" charset="0"/>
+                      </a:rPr>
+                      <m:t>+1,5 ×</m:t>
+                    </m:r>
+                    <m:sSub>
+                      <m:sSubPr>
+                        <m:ctrlPr>
+                          <a:rPr lang="pt-BR" sz="2400" b="0" i="1" dirty="0" smtClean="0">
+                            <a:latin typeface="Cambria Math" panose="02040503050406030204" pitchFamily="18" charset="0"/>
+                          </a:rPr>
+                        </m:ctrlPr>
+                      </m:sSubPr>
+                      <m:e>
+                        <m:r>
+                          <a:rPr lang="pt-BR" sz="2400" i="1" dirty="0" smtClean="0">
+                            <a:latin typeface="Cambria Math" panose="02040503050406030204" pitchFamily="18" charset="0"/>
+                          </a:rPr>
+                          <m:t>𝑑</m:t>
+                        </m:r>
+                      </m:e>
+                      <m:sub>
+                        <m:r>
+                          <a:rPr lang="pt-BR" sz="2400" i="1" dirty="0" smtClean="0">
+                            <a:latin typeface="Cambria Math" panose="02040503050406030204" pitchFamily="18" charset="0"/>
+                          </a:rPr>
+                          <m:t>𝑞</m:t>
+                        </m:r>
+                      </m:sub>
+                    </m:sSub>
+                  </m:oMath>
+                </a14:m>
+                <a:endParaRPr lang="pt-BR" sz="2400" i="1" dirty="0"/>
               </a:p>
               <a:p>
                 <a:pPr marL="457178" indent="-457178">
@@ -5507,116 +5510,38 @@
                   <a:buChar char="•"/>
                 </a:pPr>
                 <a:r>
-                  <a:rPr lang="pt-BR" sz="2800" b="1" i="1" dirty="0"/>
-                  <a:t>LS</a:t>
-                </a:r>
-                <a:r>
-                  <a:rPr lang="pt-BR" sz="2800" dirty="0"/>
-                  <a:t> (limite superior) = </a:t>
-                </a:r>
-                <a14:m>
-                  <m:oMath xmlns:m="http://schemas.openxmlformats.org/officeDocument/2006/math">
-                    <m:sSub>
-                      <m:sSubPr>
-                        <m:ctrlPr>
-                          <a:rPr lang="pt-BR" sz="2800" b="0" i="1" dirty="0" smtClean="0">
-                            <a:latin typeface="Cambria Math" panose="02040503050406030204" pitchFamily="18" charset="0"/>
-                          </a:rPr>
-                        </m:ctrlPr>
-                      </m:sSubPr>
-                      <m:e>
-                        <m:r>
-                          <a:rPr lang="pt-BR" sz="2800" i="1" dirty="0" smtClean="0">
-                            <a:latin typeface="Cambria Math" panose="02040503050406030204" pitchFamily="18" charset="0"/>
-                          </a:rPr>
-                          <m:t>𝑄</m:t>
-                        </m:r>
-                      </m:e>
-                      <m:sub>
-                        <m:r>
-                          <a:rPr lang="pt-BR" sz="2800" i="1" dirty="0" smtClean="0">
-                            <a:latin typeface="Cambria Math" panose="02040503050406030204" pitchFamily="18" charset="0"/>
-                          </a:rPr>
-                          <m:t>3</m:t>
-                        </m:r>
-                      </m:sub>
-                    </m:sSub>
-                    <m:r>
-                      <a:rPr lang="pt-BR" sz="2800" i="1" dirty="0" smtClean="0">
-                        <a:latin typeface="Cambria Math" panose="02040503050406030204" pitchFamily="18" charset="0"/>
-                      </a:rPr>
-                      <m:t>+1,5 ×</m:t>
-                    </m:r>
-                    <m:sSub>
-                      <m:sSubPr>
-                        <m:ctrlPr>
-                          <a:rPr lang="pt-BR" sz="2800" b="0" i="1" dirty="0" smtClean="0">
-                            <a:latin typeface="Cambria Math" panose="02040503050406030204" pitchFamily="18" charset="0"/>
-                          </a:rPr>
-                        </m:ctrlPr>
-                      </m:sSubPr>
-                      <m:e>
-                        <m:r>
-                          <a:rPr lang="pt-BR" sz="2800" i="1" dirty="0" smtClean="0">
-                            <a:latin typeface="Cambria Math" panose="02040503050406030204" pitchFamily="18" charset="0"/>
-                          </a:rPr>
-                          <m:t>𝑑</m:t>
-                        </m:r>
-                      </m:e>
-                      <m:sub>
-                        <m:r>
-                          <a:rPr lang="pt-BR" sz="2800" i="1" dirty="0" smtClean="0">
-                            <a:latin typeface="Cambria Math" panose="02040503050406030204" pitchFamily="18" charset="0"/>
-                          </a:rPr>
-                          <m:t>𝑞</m:t>
-                        </m:r>
-                      </m:sub>
-                    </m:sSub>
-                  </m:oMath>
-                </a14:m>
-                <a:endParaRPr lang="pt-BR" sz="2800" i="1" dirty="0"/>
-              </a:p>
-              <a:p>
-                <a:pPr marL="457178" indent="-457178">
-                  <a:lnSpc>
-                    <a:spcPct val="150000"/>
-                  </a:lnSpc>
-                  <a:buFont typeface="Arial" panose="020B0604020202020204" pitchFamily="34" charset="0"/>
-                  <a:buChar char="•"/>
-                </a:pPr>
-                <a:r>
-                  <a:rPr lang="pt-BR" sz="2800" b="1" dirty="0"/>
+                  <a:rPr lang="pt-BR" sz="2400" b="1" dirty="0"/>
                   <a:t>*</a:t>
                 </a:r>
                 <a:r>
-                  <a:rPr lang="pt-BR" sz="2800" dirty="0"/>
+                  <a:rPr lang="pt-BR" sz="2400" dirty="0"/>
                   <a:t> (asteriscos) — </a:t>
                 </a:r>
                 <a:r>
-                  <a:rPr lang="pt-BR" sz="2800" i="1" dirty="0"/>
+                  <a:rPr lang="pt-BR" sz="2400" i="1" dirty="0"/>
                   <a:t>outliers</a:t>
                 </a:r>
                 <a:r>
-                  <a:rPr lang="pt-BR" sz="2800" dirty="0"/>
+                  <a:rPr lang="pt-BR" sz="2400" dirty="0"/>
                   <a:t>: observações abaixo de </a:t>
                 </a:r>
                 <a:r>
-                  <a:rPr lang="pt-BR" sz="2800" b="1" i="1" dirty="0"/>
+                  <a:rPr lang="pt-BR" sz="2400" b="1" i="1" dirty="0"/>
                   <a:t>LI</a:t>
                 </a:r>
                 <a:r>
-                  <a:rPr lang="pt-BR" sz="2800" dirty="0"/>
+                  <a:rPr lang="pt-BR" sz="2400" dirty="0"/>
                   <a:t> ou acima de </a:t>
                 </a:r>
                 <a:r>
-                  <a:rPr lang="pt-BR" sz="2800" b="1" i="1" dirty="0"/>
+                  <a:rPr lang="pt-BR" sz="2400" b="1" i="1" dirty="0"/>
                   <a:t>LS</a:t>
                 </a:r>
               </a:p>
             </p:txBody>
           </p:sp>
         </mc:Choice>
-        <mc:Fallback xmlns="">
+        <mc:Fallback>
           <p:sp>
             <p:nvSpPr>
               <p:cNvPr id="4" name="BoxplotExplanation">
@@ -5634,7 +5559,7 @@
             <p:spPr>
               <a:xfrm>
                 <a:off x="505817" y="1156640"/>
-                <a:ext cx="5969000" cy="5295809"/>
+                <a:ext cx="5969000" cy="3487558"/>
               </a:xfrm>
               <a:prstGeom prst="rect">
                 <a:avLst/>
@@ -5642,7 +5567,7 @@
               <a:blipFill>
                 <a:blip r:embed="rId3"/>
                 <a:stretch>
-                  <a:fillRect l="-2145" b="-2419"/>
+                  <a:fillRect l="-1634" b="-2972"/>
                 </a:stretch>
               </a:blipFill>
             </p:spPr>
@@ -5674,7 +5599,7 @@
 </p:sld>
 </file>
 
-<file path=ppt/slides/slide12.xml><?xml version="1.0" encoding="utf-8"?>
+<file path=ppt/slides/slide11.xml><?xml version="1.0" encoding="utf-8"?>
 <p:sld xmlns:a="http://schemas.openxmlformats.org/drawingml/2006/main" xmlns:r="http://schemas.openxmlformats.org/officeDocument/2006/relationships" xmlns:p="http://schemas.openxmlformats.org/presentationml/2006/main">
   <p:cSld>
     <p:spTree>
@@ -5891,7 +5816,7 @@
 </p:sld>
 </file>
 
-<file path=ppt/slides/slide13.xml><?xml version="1.0" encoding="utf-8"?>
+<file path=ppt/slides/slide12.xml><?xml version="1.0" encoding="utf-8"?>
 <p:sld xmlns:a="http://schemas.openxmlformats.org/drawingml/2006/main" xmlns:r="http://schemas.openxmlformats.org/officeDocument/2006/relationships" xmlns:p="http://schemas.openxmlformats.org/presentationml/2006/main">
   <p:cSld>
     <p:spTree>
@@ -6238,7 +6163,7 @@
 </p:sld>
 </file>
 
-<file path=ppt/slides/slide14.xml><?xml version="1.0" encoding="utf-8"?>
+<file path=ppt/slides/slide13.xml><?xml version="1.0" encoding="utf-8"?>
 <p:sld xmlns:a="http://schemas.openxmlformats.org/drawingml/2006/main" xmlns:r="http://schemas.openxmlformats.org/officeDocument/2006/relationships" xmlns:p="http://schemas.openxmlformats.org/presentationml/2006/main">
   <p:cSld>
     <p:spTree>
@@ -6381,7 +6306,7 @@
 </p:sld>
 </file>
 
-<file path=ppt/slides/slide15.xml><?xml version="1.0" encoding="utf-8"?>
+<file path=ppt/slides/slide14.xml><?xml version="1.0" encoding="utf-8"?>
 <p:sld xmlns:a="http://schemas.openxmlformats.org/drawingml/2006/main" xmlns:r="http://schemas.openxmlformats.org/officeDocument/2006/relationships" xmlns:p="http://schemas.openxmlformats.org/presentationml/2006/main">
   <p:cSld>
     <p:spTree>
@@ -6497,7 +6422,7 @@
           <p:nvPr>
             <p:extLst>
               <p:ext uri="{D42A27DB-BD31-4B8C-83A1-F6EECF244321}">
-                <p14:modId xmlns:p14="http://schemas.microsoft.com/office/powerpoint/2010/main" val="825919749"/>
+                <p14:modId xmlns:p14="http://schemas.microsoft.com/office/powerpoint/2010/main" val="3286735012"/>
               </p:ext>
             </p:extLst>
           </p:nvPr>
@@ -6519,7 +6444,7 @@
           <p:nvPr>
             <p:extLst>
               <p:ext uri="{D42A27DB-BD31-4B8C-83A1-F6EECF244321}">
-                <p14:modId xmlns:p14="http://schemas.microsoft.com/office/powerpoint/2010/main" val="3677560198"/>
+                <p14:modId xmlns:p14="http://schemas.microsoft.com/office/powerpoint/2010/main" val="647140019"/>
               </p:ext>
             </p:extLst>
           </p:nvPr>
@@ -6547,7 +6472,7 @@
 </p:sld>
 </file>
 
-<file path=ppt/slides/slide16.xml><?xml version="1.0" encoding="utf-8"?>
+<file path=ppt/slides/slide15.xml><?xml version="1.0" encoding="utf-8"?>
 <p:sld xmlns:a="http://schemas.openxmlformats.org/drawingml/2006/main" xmlns:r="http://schemas.openxmlformats.org/officeDocument/2006/relationships" xmlns:p="http://schemas.openxmlformats.org/presentationml/2006/main">
   <p:cSld>
     <p:spTree>
@@ -8786,7 +8711,7 @@
 </p:sld>
 </file>
 
-<file path=ppt/slides/slide17.xml><?xml version="1.0" encoding="utf-8"?>
+<file path=ppt/slides/slide16.xml><?xml version="1.0" encoding="utf-8"?>
 <p:sld xmlns:a="http://schemas.openxmlformats.org/drawingml/2006/main" xmlns:r="http://schemas.openxmlformats.org/officeDocument/2006/relationships" xmlns:p="http://schemas.openxmlformats.org/presentationml/2006/main">
   <p:cSld>
     <p:spTree>
@@ -9161,8 +9086,8 @@
           <a:chExt cx="0" cy="0"/>
         </a:xfrm>
       </p:grpSpPr>
-      <mc:AlternateContent xmlns:mc="http://schemas.openxmlformats.org/markup-compatibility/2006">
-        <mc:Choice xmlns:a14="http://schemas.microsoft.com/office/drawing/2010/main" Requires="a14">
+      <mc:AlternateContent xmlns:mc="http://schemas.openxmlformats.org/markup-compatibility/2006" xmlns:a14="http://schemas.microsoft.com/office/drawing/2010/main">
+        <mc:Choice Requires="a14">
           <p:sp>
             <p:nvSpPr>
               <p:cNvPr id="6" name="CaixaDeTexto 5">
@@ -9814,7 +9739,7 @@
             </p:txBody>
           </p:sp>
         </mc:Choice>
-        <mc:Fallback>
+        <mc:Fallback xmlns="">
           <p:sp>
             <p:nvSpPr>
               <p:cNvPr id="6" name="CaixaDeTexto 5">
@@ -9938,7 +9863,7 @@
         </p:nvSpPr>
         <p:spPr>
           <a:xfrm>
-            <a:off x="650240" y="1458354"/>
+            <a:off x="557475" y="451189"/>
             <a:ext cx="11180365" cy="5047536"/>
           </a:xfrm>
           <a:prstGeom prst="rect">
@@ -10524,8 +10449,8 @@
           <a:chExt cx="0" cy="0"/>
         </a:xfrm>
       </p:grpSpPr>
-      <mc:AlternateContent xmlns:mc="http://schemas.openxmlformats.org/markup-compatibility/2006" xmlns:a14="http://schemas.microsoft.com/office/drawing/2010/main">
-        <mc:Choice Requires="a14">
+      <mc:AlternateContent xmlns:mc="http://schemas.openxmlformats.org/markup-compatibility/2006">
+        <mc:Choice xmlns:a14="http://schemas.microsoft.com/office/drawing/2010/main" Requires="a14">
           <p:sp>
             <p:nvSpPr>
               <p:cNvPr id="6" name="CaixaDeTexto 5">
@@ -10613,13 +10538,13 @@
                       <a:rPr lang="pt-BR" sz="2800" b="0" i="0" smtClean="0">
                         <a:latin typeface="Cambria Math" panose="02040503050406030204" pitchFamily="18" charset="0"/>
                       </a:rPr>
-                      <m:t> − </m:t>
+                      <m:t> </m:t>
                     </m:r>
                   </m:oMath>
                 </a14:m>
                 <a:r>
                   <a:rPr lang="pt-BR" sz="2800" dirty="0"/>
-                  <a:t>1 quartil</a:t>
+                  <a:t>- 1 quartil</a:t>
                 </a:r>
               </a:p>
               <a:p>
@@ -10804,7 +10729,7 @@
             </p:txBody>
           </p:sp>
         </mc:Choice>
-        <mc:Fallback xmlns="">
+        <mc:Fallback>
           <p:sp>
             <p:nvSpPr>
               <p:cNvPr id="6" name="CaixaDeTexto 5">
@@ -11228,8 +11153,8 @@
           <a:chExt cx="0" cy="0"/>
         </a:xfrm>
       </p:grpSpPr>
-      <mc:AlternateContent xmlns:mc="http://schemas.openxmlformats.org/markup-compatibility/2006" xmlns:a14="http://schemas.microsoft.com/office/drawing/2010/main">
-        <mc:Choice Requires="a14">
+      <mc:AlternateContent xmlns:mc="http://schemas.openxmlformats.org/markup-compatibility/2006">
+        <mc:Choice xmlns:a14="http://schemas.microsoft.com/office/drawing/2010/main" Requires="a14">
           <p:sp>
             <p:nvSpPr>
               <p:cNvPr id="6" name="CaixaDeTexto 5">
@@ -11244,7 +11169,7 @@
             </p:nvSpPr>
             <p:spPr>
               <a:xfrm>
-                <a:off x="701040" y="785254"/>
+                <a:off x="621527" y="387689"/>
                 <a:ext cx="11180365" cy="5600764"/>
               </a:xfrm>
               <a:prstGeom prst="rect">
@@ -11266,6 +11191,33 @@
                 <a:r>
                   <a:rPr lang="pt-BR" sz="2600" b="1" dirty="0"/>
                   <a:t>Mais algumas definições</a:t>
+                </a:r>
+              </a:p>
+              <a:p>
+                <a:pPr marL="457200" indent="-457200">
+                  <a:lnSpc>
+                    <a:spcPct val="150000"/>
+                  </a:lnSpc>
+                  <a:buFont typeface="Arial" panose="020B0604020202020204" pitchFamily="34" charset="0"/>
+                  <a:buChar char="•"/>
+                </a:pPr>
+                <a:r>
+                  <a:rPr lang="pt-BR" sz="2600" b="1" dirty="0"/>
+                  <a:t>Medida resistente</a:t>
+                </a:r>
+                <a:endParaRPr lang="pt-BR" sz="2600" dirty="0"/>
+              </a:p>
+              <a:p>
+                <a:pPr marL="914389" lvl="1" indent="-457200">
+                  <a:lnSpc>
+                    <a:spcPct val="150000"/>
+                  </a:lnSpc>
+                  <a:buFont typeface="Arial" panose="020B0604020202020204" pitchFamily="34" charset="0"/>
+                  <a:buChar char="•"/>
+                </a:pPr>
+                <a:r>
+                  <a:rPr lang="pt-BR" sz="2600" dirty="0"/>
+                  <a:t>Pouco afetada por mudanças em poucos dados</a:t>
                 </a:r>
               </a:p>
               <a:p>
@@ -11381,33 +11333,6 @@
                   </m:oMath>
                 </a14:m>
                 <a:endParaRPr lang="pt-BR" sz="2600" dirty="0"/>
-              </a:p>
-              <a:p>
-                <a:pPr marL="457200" indent="-457200">
-                  <a:lnSpc>
-                    <a:spcPct val="150000"/>
-                  </a:lnSpc>
-                  <a:buFont typeface="Arial" panose="020B0604020202020204" pitchFamily="34" charset="0"/>
-                  <a:buChar char="•"/>
-                </a:pPr>
-                <a:r>
-                  <a:rPr lang="pt-BR" sz="2600" b="1" dirty="0"/>
-                  <a:t>Medida resistente</a:t>
-                </a:r>
-                <a:endParaRPr lang="pt-BR" sz="2600" dirty="0"/>
-              </a:p>
-              <a:p>
-                <a:pPr marL="914389" lvl="1" indent="-457200">
-                  <a:lnSpc>
-                    <a:spcPct val="150000"/>
-                  </a:lnSpc>
-                  <a:buFont typeface="Arial" panose="020B0604020202020204" pitchFamily="34" charset="0"/>
-                  <a:buChar char="•"/>
-                </a:pPr>
-                <a:r>
-                  <a:rPr lang="pt-BR" sz="2600" dirty="0"/>
-                  <a:t>Pouco afetada por mudanças em poucos dados</a:t>
-                </a:r>
               </a:p>
               <a:p>
                 <a:pPr marL="457200" indent="-457200">
@@ -11614,7 +11539,7 @@
             </p:txBody>
           </p:sp>
         </mc:Choice>
-        <mc:Fallback xmlns="">
+        <mc:Fallback>
           <p:sp>
             <p:nvSpPr>
               <p:cNvPr id="6" name="CaixaDeTexto 5">
@@ -11631,7 +11556,7 @@
             </p:nvSpPr>
             <p:spPr>
               <a:xfrm>
-                <a:off x="701040" y="785254"/>
+                <a:off x="621527" y="387689"/>
                 <a:ext cx="11180365" cy="5600764"/>
               </a:xfrm>
               <a:prstGeom prst="rect">
@@ -11694,6 +11619,36 @@
           </a:p>
         </p:txBody>
       </p:sp>
+      <p:pic>
+        <p:nvPicPr>
+          <p:cNvPr id="2" name="Imagem 1">
+            <a:extLst>
+              <a:ext uri="{FF2B5EF4-FFF2-40B4-BE49-F238E27FC236}">
+                <a16:creationId xmlns:a16="http://schemas.microsoft.com/office/drawing/2014/main" id="{2B8C5C3B-6FE8-4CB8-9B68-5D9B4E620FFF}"/>
+              </a:ext>
+            </a:extLst>
+          </p:cNvPr>
+          <p:cNvPicPr>
+            <a:picLocks noChangeAspect="1"/>
+          </p:cNvPicPr>
+          <p:nvPr/>
+        </p:nvPicPr>
+        <p:blipFill>
+          <a:blip r:embed="rId3"/>
+          <a:stretch>
+            <a:fillRect/>
+          </a:stretch>
+        </p:blipFill>
+        <p:spPr>
+          <a:xfrm>
+            <a:off x="5359301" y="2293958"/>
+            <a:ext cx="6442591" cy="4176353"/>
+          </a:xfrm>
+          <a:prstGeom prst="rect">
+            <a:avLst/>
+          </a:prstGeom>
+        </p:spPr>
+      </p:pic>
     </p:spTree>
     <p:extLst>
       <p:ext uri="{BB962C8B-B14F-4D97-AF65-F5344CB8AC3E}">

</xml_diff>